<commit_message>
docs: enlazar tablero Scrum y refinar entregables
</commit_message>
<xml_diff>
--- a/entregables/04-Exposicion-Organizacion-Git.pptx
+++ b/entregables/04-Exposicion-Organizacion-Git.pptx
@@ -2,17 +2,17 @@
 <file path=ppt/presentation.xml><?xml version="1.0" encoding="utf-8"?>
 <p:presentation xmlns:p="http://schemas.openxmlformats.org/presentationml/2006/main">
   <p:sldMasterIdLst>
-    <p:sldMasterId xmlns:r="http://schemas.openxmlformats.org/officeDocument/2006/relationships" id="2147483648" r:id="R6e72fc6d63404591"/>
+    <p:sldMasterId xmlns:r="http://schemas.openxmlformats.org/officeDocument/2006/relationships" id="2147483648" r:id="R6fa76e75945a4c9e"/>
   </p:sldMasterIdLst>
   <p:notesMasterIdLst>
-    <p:notesMasterId xmlns:r="http://schemas.openxmlformats.org/officeDocument/2006/relationships" r:id="Rb5a0a48c13994704"/>
+    <p:notesMasterId xmlns:r="http://schemas.openxmlformats.org/officeDocument/2006/relationships" r:id="R173ddc3426d74769"/>
   </p:notesMasterIdLst>
   <p:sldIdLst>
-    <p:sldId xmlns:r="http://schemas.openxmlformats.org/officeDocument/2006/relationships" id="256" r:id="R165ce3f4ea0d4194"/>
-    <p:sldId xmlns:r="http://schemas.openxmlformats.org/officeDocument/2006/relationships" id="257" r:id="Reaa1d12fa8034a3d"/>
-    <p:sldId xmlns:r="http://schemas.openxmlformats.org/officeDocument/2006/relationships" id="258" r:id="R29d60e2adcc5443a"/>
-    <p:sldId xmlns:r="http://schemas.openxmlformats.org/officeDocument/2006/relationships" id="259" r:id="R1a7bf3b388f1445b"/>
-    <p:sldId xmlns:r="http://schemas.openxmlformats.org/officeDocument/2006/relationships" id="260" r:id="R6206e881092f4b84"/>
+    <p:sldId xmlns:r="http://schemas.openxmlformats.org/officeDocument/2006/relationships" id="256" r:id="Rb706328c3884432f"/>
+    <p:sldId xmlns:r="http://schemas.openxmlformats.org/officeDocument/2006/relationships" id="257" r:id="Racd5acf5894948dd"/>
+    <p:sldId xmlns:r="http://schemas.openxmlformats.org/officeDocument/2006/relationships" id="258" r:id="Re47d458352b34d7e"/>
+    <p:sldId xmlns:r="http://schemas.openxmlformats.org/officeDocument/2006/relationships" id="259" r:id="Rb4fe19c4297f4fdf"/>
+    <p:sldId xmlns:r="http://schemas.openxmlformats.org/officeDocument/2006/relationships" id="260" r:id="Rdfc0f6162e9246e7"/>
   </p:sldIdLst>
   <p:sldSz cx="12192000" cy="6858000"/>
   <p:notesSz cx="6858000" cy="9144000"/>
@@ -2519,12 +2519,12 @@
   </p:cSld>
   <p:clrMap bg1="lt1" tx1="dk1" bg2="lt2" tx2="dk2" accent1="accent1" accent2="accent2" accent3="accent3" accent4="accent4" accent5="accent5" accent6="accent6" hlink="hlink" folHlink="folHlink"/>
   <p:sldLayoutIdLst>
-    <p:sldLayoutId xmlns:r="http://schemas.openxmlformats.org/officeDocument/2006/relationships" id="2147483649" r:id="R747a1f947ce0410f"/>
-    <p:sldLayoutId xmlns:r="http://schemas.openxmlformats.org/officeDocument/2006/relationships" id="2147483650" r:id="Rc6fa69cb987f4b08"/>
-    <p:sldLayoutId xmlns:r="http://schemas.openxmlformats.org/officeDocument/2006/relationships" id="2147483651" r:id="Rb102390bc9534b3d"/>
-    <p:sldLayoutId xmlns:r="http://schemas.openxmlformats.org/officeDocument/2006/relationships" id="2147483652" r:id="R9e2ca5766662493e"/>
-    <p:sldLayoutId xmlns:r="http://schemas.openxmlformats.org/officeDocument/2006/relationships" id="2147483653" r:id="R7fb04843a37047f0"/>
-    <p:sldLayoutId xmlns:r="http://schemas.openxmlformats.org/officeDocument/2006/relationships" id="2147483654" r:id="R68e85bbeba4d4402"/>
+    <p:sldLayoutId xmlns:r="http://schemas.openxmlformats.org/officeDocument/2006/relationships" id="2147483649" r:id="Rf6b326c0d07e4933"/>
+    <p:sldLayoutId xmlns:r="http://schemas.openxmlformats.org/officeDocument/2006/relationships" id="2147483650" r:id="Rc38c23105dc34593"/>
+    <p:sldLayoutId xmlns:r="http://schemas.openxmlformats.org/officeDocument/2006/relationships" id="2147483651" r:id="Rc5935b1877b646ba"/>
+    <p:sldLayoutId xmlns:r="http://schemas.openxmlformats.org/officeDocument/2006/relationships" id="2147483652" r:id="R1e409eca82ce464e"/>
+    <p:sldLayoutId xmlns:r="http://schemas.openxmlformats.org/officeDocument/2006/relationships" id="2147483653" r:id="R13cca8fddeaf4434"/>
+    <p:sldLayoutId xmlns:r="http://schemas.openxmlformats.org/officeDocument/2006/relationships" id="2147483654" r:id="Rb1c20ab800b54df2"/>
   </p:sldLayoutIdLst>
   <p:txStyles>
     <p:titleStyle>
@@ -6326,7 +6326,7 @@
                   <a:srgbClr val="1D6A96"/>
                 </a:solidFill>
               </a:rPr>
-              <a:t>Pull request → revisión de otro integrante → integración en main</a:t>
+              <a:t>Issues SQA-01–10 · tablero público → Pull Request → revisión → main</a:t>
             </a:r>
           </a:p>
         </p:txBody>

</xml_diff>

<commit_message>
docs: finalizar entregables de pruebas y Scrum
</commit_message>
<xml_diff>
--- a/entregables/04-Exposicion-Organizacion-Git.pptx
+++ b/entregables/04-Exposicion-Organizacion-Git.pptx
@@ -2,17 +2,17 @@
 <file path=ppt/presentation.xml><?xml version="1.0" encoding="utf-8"?>
 <p:presentation xmlns:p="http://schemas.openxmlformats.org/presentationml/2006/main">
   <p:sldMasterIdLst>
-    <p:sldMasterId xmlns:r="http://schemas.openxmlformats.org/officeDocument/2006/relationships" id="2147483648" r:id="R6fa76e75945a4c9e"/>
+    <p:sldMasterId xmlns:r="http://schemas.openxmlformats.org/officeDocument/2006/relationships" id="2147483648" r:id="Rb6499e322cb24b54"/>
   </p:sldMasterIdLst>
   <p:notesMasterIdLst>
-    <p:notesMasterId xmlns:r="http://schemas.openxmlformats.org/officeDocument/2006/relationships" r:id="R173ddc3426d74769"/>
+    <p:notesMasterId xmlns:r="http://schemas.openxmlformats.org/officeDocument/2006/relationships" r:id="Re514ab48f2e847b6"/>
   </p:notesMasterIdLst>
   <p:sldIdLst>
-    <p:sldId xmlns:r="http://schemas.openxmlformats.org/officeDocument/2006/relationships" id="256" r:id="Rb706328c3884432f"/>
-    <p:sldId xmlns:r="http://schemas.openxmlformats.org/officeDocument/2006/relationships" id="257" r:id="Racd5acf5894948dd"/>
-    <p:sldId xmlns:r="http://schemas.openxmlformats.org/officeDocument/2006/relationships" id="258" r:id="Re47d458352b34d7e"/>
-    <p:sldId xmlns:r="http://schemas.openxmlformats.org/officeDocument/2006/relationships" id="259" r:id="Rb4fe19c4297f4fdf"/>
-    <p:sldId xmlns:r="http://schemas.openxmlformats.org/officeDocument/2006/relationships" id="260" r:id="Rdfc0f6162e9246e7"/>
+    <p:sldId xmlns:r="http://schemas.openxmlformats.org/officeDocument/2006/relationships" id="256" r:id="R2f2822a53e1641f7"/>
+    <p:sldId xmlns:r="http://schemas.openxmlformats.org/officeDocument/2006/relationships" id="257" r:id="R0588ab1294ce4512"/>
+    <p:sldId xmlns:r="http://schemas.openxmlformats.org/officeDocument/2006/relationships" id="258" r:id="R6779cbd13a0c40c7"/>
+    <p:sldId xmlns:r="http://schemas.openxmlformats.org/officeDocument/2006/relationships" id="259" r:id="R6cdf85c533fc410c"/>
+    <p:sldId xmlns:r="http://schemas.openxmlformats.org/officeDocument/2006/relationships" id="260" r:id="R8ddf9a6acda349d4"/>
   </p:sldIdLst>
   <p:sldSz cx="12192000" cy="6858000"/>
   <p:notesSz cx="6858000" cy="9144000"/>
@@ -2519,12 +2519,12 @@
   </p:cSld>
   <p:clrMap bg1="lt1" tx1="dk1" bg2="lt2" tx2="dk2" accent1="accent1" accent2="accent2" accent3="accent3" accent4="accent4" accent5="accent5" accent6="accent6" hlink="hlink" folHlink="folHlink"/>
   <p:sldLayoutIdLst>
-    <p:sldLayoutId xmlns:r="http://schemas.openxmlformats.org/officeDocument/2006/relationships" id="2147483649" r:id="Rf6b326c0d07e4933"/>
-    <p:sldLayoutId xmlns:r="http://schemas.openxmlformats.org/officeDocument/2006/relationships" id="2147483650" r:id="Rc38c23105dc34593"/>
-    <p:sldLayoutId xmlns:r="http://schemas.openxmlformats.org/officeDocument/2006/relationships" id="2147483651" r:id="Rc5935b1877b646ba"/>
-    <p:sldLayoutId xmlns:r="http://schemas.openxmlformats.org/officeDocument/2006/relationships" id="2147483652" r:id="R1e409eca82ce464e"/>
-    <p:sldLayoutId xmlns:r="http://schemas.openxmlformats.org/officeDocument/2006/relationships" id="2147483653" r:id="R13cca8fddeaf4434"/>
-    <p:sldLayoutId xmlns:r="http://schemas.openxmlformats.org/officeDocument/2006/relationships" id="2147483654" r:id="Rb1c20ab800b54df2"/>
+    <p:sldLayoutId xmlns:r="http://schemas.openxmlformats.org/officeDocument/2006/relationships" id="2147483649" r:id="R76dfcb92fc774555"/>
+    <p:sldLayoutId xmlns:r="http://schemas.openxmlformats.org/officeDocument/2006/relationships" id="2147483650" r:id="R0d9f1d370ca44b96"/>
+    <p:sldLayoutId xmlns:r="http://schemas.openxmlformats.org/officeDocument/2006/relationships" id="2147483651" r:id="R533373000c1b4508"/>
+    <p:sldLayoutId xmlns:r="http://schemas.openxmlformats.org/officeDocument/2006/relationships" id="2147483652" r:id="R232328a8d7ee4839"/>
+    <p:sldLayoutId xmlns:r="http://schemas.openxmlformats.org/officeDocument/2006/relationships" id="2147483653" r:id="R6f84606337e1418f"/>
+    <p:sldLayoutId xmlns:r="http://schemas.openxmlformats.org/officeDocument/2006/relationships" id="2147483654" r:id="Rb5dd7c9d189a4cbd"/>
   </p:sldLayoutIdLst>
   <p:txStyles>
     <p:titleStyle>
@@ -3979,25 +3979,7 @@
                   <a:srgbClr val="12304A"/>
                 </a:solidFill>
               </a:rPr>
-              <a:t>Cronograma: Docker/MySQL 12/10 (realizado)</a:t>
-            </a:r>
-          </a:p>
-          <a:p xmlns:a="http://schemas.openxmlformats.org/drawingml/2006/main">
-            <a:pPr>
-              <a:buNone/>
-              <a:defRPr sz="1800" b="1">
-                <a:solidFill>
-                  <a:srgbClr val="12304A"/>
-                </a:solidFill>
-              </a:defRPr>
-            </a:pPr>
-            <a:r>
-              <a:rPr sz="1800" b="1">
-                <a:solidFill>
-                  <a:srgbClr val="12304A"/>
-                </a:solidFill>
-              </a:rPr>
-              <a:t>Planificación 14/10 · seguimientos 15–18/10 (planificados) · exposición 19/10.</a:t>
+              <a:t>Cronograma: entorno Docker/MySQL 12/10 · organización de tareas 14/10 · seguimiento y revisión 15–18/10 · presentación 19/10.</a:t>
             </a:r>
           </a:p>
         </p:txBody>
@@ -4203,7 +4185,7 @@
                   <a:srgbClr val="526777"/>
                 </a:solidFill>
               </a:rPr>
-              <a:t>22 casos para las páginas funcionales; el alta de otro administrador queda como brecha.</a:t>
+              <a:t>22 casos automatizados para los flujos disponibles; CP-23 documenta la brecha de alta de administrador.</a:t>
             </a:r>
           </a:p>
         </p:txBody>
@@ -4734,7 +4716,7 @@
                   <a:srgbClr val="172B3A"/>
                 </a:solidFill>
               </a:rPr>
-              <a:t>Registrar otro administrador no está disponible en esta versión; se documenta como pendiente.</a:t>
+              <a:t>Esta versión del portal no ofrece alta de administradores. CP-23 identifica y describe esta brecha funcional.</a:t>
             </a:r>
           </a:p>
         </p:txBody>
@@ -5117,7 +5099,7 @@
                   <a:srgbClr val="12304A"/>
                 </a:solidFill>
               </a:rPr>
-              <a:t>Levantar app y MySQL</a:t>
+              <a:t>Entorno Docker y MySQL</a:t>
             </a:r>
           </a:p>
         </p:txBody>
@@ -5235,7 +5217,7 @@
                   <a:srgbClr val="12304A"/>
                 </a:solidFill>
               </a:rPr>
-              <a:t>Abrir Cypress en VS Code</a:t>
+              <a:t>Suite E2E en Cypress</a:t>
             </a:r>
           </a:p>
         </p:txBody>
@@ -5353,7 +5335,7 @@
                   <a:srgbClr val="12304A"/>
                 </a:solidFill>
               </a:rPr>
-              <a:t>Revisar resultado y capturas</a:t>
+              <a:t>Resultado y trazabilidad</a:t>
             </a:r>
           </a:p>
         </p:txBody>
@@ -5412,7 +5394,25 @@
                   <a:srgbClr val="12304A"/>
                 </a:solidFill>
               </a:rPr>
-              <a:t>Cypress 16.1.1 · 22 passing · 0 failing · 0 pending (14/10/2026).</a:t>
+              <a:t>Ejecución local registrada · 14/10/2026</a:t>
+            </a:r>
+          </a:p>
+          <a:p xmlns:a="http://schemas.openxmlformats.org/drawingml/2006/main">
+            <a:pPr>
+              <a:buNone/>
+              <a:defRPr sz="1875" b="1">
+                <a:solidFill>
+                  <a:srgbClr val="12304A"/>
+                </a:solidFill>
+              </a:defRPr>
+            </a:pPr>
+            <a:r>
+              <a:rPr sz="1875" b="1">
+                <a:solidFill>
+                  <a:srgbClr val="12304A"/>
+                </a:solidFill>
+              </a:rPr>
+              <a:t>22 passing · 0 failing · 0 pending</a:t>
             </a:r>
           </a:p>
         </p:txBody>
@@ -5618,7 +5618,7 @@
                   <a:srgbClr val="526777"/>
                 </a:solidFill>
               </a:rPr>
-              <a:t>Planificación 14/10 · seguimientos 15–18/10 · ensayo 18/10.</a:t>
+              <a:t>Cronograma del 14 al 19/10: planificación, seguimiento y revisión; presentación el 19/10.</a:t>
             </a:r>
           </a:p>
         </p:txBody>

</xml_diff>